<commit_message>
PPTX: render real title slide and add page numbers
build_pptx.py:
- Fix slide 0: the ## 0. Title heading matched the regular content-
  slide regex first, so the title slide was being built as a regular
  blank content slide. Now numbers parse first and num==0 routes to
  the title-slide builder.
- Add 'N / total' page number bottom-right on every slide except the
  title slide itself.
</commit_message>
<xml_diff>
--- a/talks/cpp-russia-lsm-compaction.pptx
+++ b/talks/cpp-russia-lsm-compaction.pptx
@@ -5215,8 +5215,8 @@
         </p:nvSpPr>
         <p:spPr>
           <a:xfrm>
-            <a:off x="365760" y="274320"/>
-            <a:ext cx="11460175" cy="640080"/>
+            <a:off x="365760" y="1828800"/>
+            <a:ext cx="11460175" cy="1371600"/>
           </a:xfrm>
           <a:prstGeom prst="rect">
             <a:avLst/>
@@ -5229,14 +5229,82 @@
           </a:bodyPr>
           <a:lstStyle/>
           <a:p>
-            <a:pPr algn="l"/>
-            <a:r>
-              <a:rPr sz="3000" b="1">
-                <a:solidFill>
-                  <a:srgbClr val="2B1321"/>
-                </a:solidFill>
-              </a:rPr>
-              <a:t>Title</a:t>
+            <a:pPr algn="ctr"/>
+            <a:r>
+              <a:rPr sz="4400" b="1">
+                <a:solidFill>
+                  <a:srgbClr val="2B1321"/>
+                </a:solidFill>
+              </a:rPr>
+              <a:t>Стратегии слияния (compaction strategies) в LSM-деревьях</a:t>
+            </a:r>
+          </a:p>
+        </p:txBody>
+      </p:sp>
+      <p:sp>
+        <p:nvSpPr>
+          <p:cNvPr id="3" name="TextBox 2"/>
+          <p:cNvSpPr txBox="1"/>
+          <p:nvPr/>
+        </p:nvSpPr>
+        <p:spPr>
+          <a:xfrm>
+            <a:off x="365760" y="3291840"/>
+            <a:ext cx="11460175" cy="548640"/>
+          </a:xfrm>
+          <a:prstGeom prst="rect">
+            <a:avLst/>
+          </a:prstGeom>
+          <a:noFill/>
+        </p:spPr>
+        <p:txBody>
+          <a:bodyPr wrap="square">
+            <a:spAutoFit/>
+          </a:bodyPr>
+          <a:lstStyle/>
+          <a:p>
+            <a:pPr algn="ctr"/>
+            <a:r>
+              <a:rPr sz="2400" i="1">
+                <a:solidFill>
+                  <a:srgbClr val="737A82"/>
+                </a:solidFill>
+              </a:rPr>
+              <a:t>За пределами Leveled и Tiered</a:t>
+            </a:r>
+          </a:p>
+        </p:txBody>
+      </p:sp>
+      <p:sp>
+        <p:nvSpPr>
+          <p:cNvPr id="4" name="TextBox 3"/>
+          <p:cNvSpPr txBox="1"/>
+          <p:nvPr/>
+        </p:nvSpPr>
+        <p:spPr>
+          <a:xfrm>
+            <a:off x="365760" y="5029200"/>
+            <a:ext cx="11460175" cy="457200"/>
+          </a:xfrm>
+          <a:prstGeom prst="rect">
+            <a:avLst/>
+          </a:prstGeom>
+          <a:noFill/>
+        </p:spPr>
+        <p:txBody>
+          <a:bodyPr wrap="square">
+            <a:spAutoFit/>
+          </a:bodyPr>
+          <a:lstStyle/>
+          <a:p>
+            <a:pPr algn="ctr"/>
+            <a:r>
+              <a:rPr sz="1800">
+                <a:solidFill>
+                  <a:srgbClr val="2B1321"/>
+                </a:solidFill>
+              </a:rPr>
+              <a:t>Константин Осипов — C++ Russia, 17 мая 2026</a:t>
             </a:r>
           </a:p>
         </p:txBody>
@@ -5384,6 +5452,40 @@
           </a:p>
         </p:txBody>
       </p:sp>
+      <p:sp>
+        <p:nvSpPr>
+          <p:cNvPr id="5" name="TextBox 4"/>
+          <p:cNvSpPr txBox="1"/>
+          <p:nvPr/>
+        </p:nvSpPr>
+        <p:spPr>
+          <a:xfrm>
+            <a:off x="10911535" y="6492240"/>
+            <a:ext cx="1097280" cy="274320"/>
+          </a:xfrm>
+          <a:prstGeom prst="rect">
+            <a:avLst/>
+          </a:prstGeom>
+          <a:noFill/>
+        </p:spPr>
+        <p:txBody>
+          <a:bodyPr wrap="none">
+            <a:spAutoFit/>
+          </a:bodyPr>
+          <a:lstStyle/>
+          <a:p>
+            <a:pPr algn="r"/>
+            <a:r>
+              <a:rPr sz="1100">
+                <a:solidFill>
+                  <a:srgbClr val="737A82"/>
+                </a:solidFill>
+              </a:rPr>
+              <a:t>9 / 23</a:t>
+            </a:r>
+          </a:p>
+        </p:txBody>
+      </p:sp>
     </p:spTree>
   </p:cSld>
   <p:clrMapOvr>
@@ -5516,6 +5618,40 @@
           </a:p>
         </p:txBody>
       </p:sp>
+      <p:sp>
+        <p:nvSpPr>
+          <p:cNvPr id="5" name="TextBox 4"/>
+          <p:cNvSpPr txBox="1"/>
+          <p:nvPr/>
+        </p:nvSpPr>
+        <p:spPr>
+          <a:xfrm>
+            <a:off x="10911535" y="6492240"/>
+            <a:ext cx="1097280" cy="274320"/>
+          </a:xfrm>
+          <a:prstGeom prst="rect">
+            <a:avLst/>
+          </a:prstGeom>
+          <a:noFill/>
+        </p:spPr>
+        <p:txBody>
+          <a:bodyPr wrap="none">
+            <a:spAutoFit/>
+          </a:bodyPr>
+          <a:lstStyle/>
+          <a:p>
+            <a:pPr algn="r"/>
+            <a:r>
+              <a:rPr sz="1100">
+                <a:solidFill>
+                  <a:srgbClr val="737A82"/>
+                </a:solidFill>
+              </a:rPr>
+              <a:t>10 / 23</a:t>
+            </a:r>
+          </a:p>
+        </p:txBody>
+      </p:sp>
     </p:spTree>
   </p:cSld>
   <p:clrMapOvr>
@@ -5672,6 +5808,40 @@
           </a:p>
         </p:txBody>
       </p:sp>
+      <p:sp>
+        <p:nvSpPr>
+          <p:cNvPr id="6" name="TextBox 5"/>
+          <p:cNvSpPr txBox="1"/>
+          <p:nvPr/>
+        </p:nvSpPr>
+        <p:spPr>
+          <a:xfrm>
+            <a:off x="10911535" y="6492240"/>
+            <a:ext cx="1097280" cy="274320"/>
+          </a:xfrm>
+          <a:prstGeom prst="rect">
+            <a:avLst/>
+          </a:prstGeom>
+          <a:noFill/>
+        </p:spPr>
+        <p:txBody>
+          <a:bodyPr wrap="none">
+            <a:spAutoFit/>
+          </a:bodyPr>
+          <a:lstStyle/>
+          <a:p>
+            <a:pPr algn="r"/>
+            <a:r>
+              <a:rPr sz="1100">
+                <a:solidFill>
+                  <a:srgbClr val="737A82"/>
+                </a:solidFill>
+              </a:rPr>
+              <a:t>11 / 23</a:t>
+            </a:r>
+          </a:p>
+        </p:txBody>
+      </p:sp>
     </p:spTree>
   </p:cSld>
   <p:clrMapOvr>
@@ -5815,6 +5985,40 @@
           </a:p>
         </p:txBody>
       </p:sp>
+      <p:sp>
+        <p:nvSpPr>
+          <p:cNvPr id="5" name="TextBox 4"/>
+          <p:cNvSpPr txBox="1"/>
+          <p:nvPr/>
+        </p:nvSpPr>
+        <p:spPr>
+          <a:xfrm>
+            <a:off x="10911535" y="6492240"/>
+            <a:ext cx="1097280" cy="274320"/>
+          </a:xfrm>
+          <a:prstGeom prst="rect">
+            <a:avLst/>
+          </a:prstGeom>
+          <a:noFill/>
+        </p:spPr>
+        <p:txBody>
+          <a:bodyPr wrap="none">
+            <a:spAutoFit/>
+          </a:bodyPr>
+          <a:lstStyle/>
+          <a:p>
+            <a:pPr algn="r"/>
+            <a:r>
+              <a:rPr sz="1100">
+                <a:solidFill>
+                  <a:srgbClr val="737A82"/>
+                </a:solidFill>
+              </a:rPr>
+              <a:t>12 / 23</a:t>
+            </a:r>
+          </a:p>
+        </p:txBody>
+      </p:sp>
     </p:spTree>
   </p:cSld>
   <p:clrMapOvr>
@@ -5958,6 +6162,40 @@
           </a:p>
         </p:txBody>
       </p:sp>
+      <p:sp>
+        <p:nvSpPr>
+          <p:cNvPr id="5" name="TextBox 4"/>
+          <p:cNvSpPr txBox="1"/>
+          <p:nvPr/>
+        </p:nvSpPr>
+        <p:spPr>
+          <a:xfrm>
+            <a:off x="10911535" y="6492240"/>
+            <a:ext cx="1097280" cy="274320"/>
+          </a:xfrm>
+          <a:prstGeom prst="rect">
+            <a:avLst/>
+          </a:prstGeom>
+          <a:noFill/>
+        </p:spPr>
+        <p:txBody>
+          <a:bodyPr wrap="none">
+            <a:spAutoFit/>
+          </a:bodyPr>
+          <a:lstStyle/>
+          <a:p>
+            <a:pPr algn="r"/>
+            <a:r>
+              <a:rPr sz="1100">
+                <a:solidFill>
+                  <a:srgbClr val="737A82"/>
+                </a:solidFill>
+              </a:rPr>
+              <a:t>13 / 23</a:t>
+            </a:r>
+          </a:p>
+        </p:txBody>
+      </p:sp>
     </p:spTree>
   </p:cSld>
   <p:clrMapOvr>
@@ -6090,6 +6328,40 @@
           </a:p>
         </p:txBody>
       </p:sp>
+      <p:sp>
+        <p:nvSpPr>
+          <p:cNvPr id="5" name="TextBox 4"/>
+          <p:cNvSpPr txBox="1"/>
+          <p:nvPr/>
+        </p:nvSpPr>
+        <p:spPr>
+          <a:xfrm>
+            <a:off x="10911535" y="6492240"/>
+            <a:ext cx="1097280" cy="274320"/>
+          </a:xfrm>
+          <a:prstGeom prst="rect">
+            <a:avLst/>
+          </a:prstGeom>
+          <a:noFill/>
+        </p:spPr>
+        <p:txBody>
+          <a:bodyPr wrap="none">
+            <a:spAutoFit/>
+          </a:bodyPr>
+          <a:lstStyle/>
+          <a:p>
+            <a:pPr algn="r"/>
+            <a:r>
+              <a:rPr sz="1100">
+                <a:solidFill>
+                  <a:srgbClr val="737A82"/>
+                </a:solidFill>
+              </a:rPr>
+              <a:t>14 / 23</a:t>
+            </a:r>
+          </a:p>
+        </p:txBody>
+      </p:sp>
     </p:spTree>
   </p:cSld>
   <p:clrMapOvr>
@@ -6187,6 +6459,40 @@
           </a:p>
         </p:txBody>
       </p:sp>
+      <p:sp>
+        <p:nvSpPr>
+          <p:cNvPr id="4" name="TextBox 3"/>
+          <p:cNvSpPr txBox="1"/>
+          <p:nvPr/>
+        </p:nvSpPr>
+        <p:spPr>
+          <a:xfrm>
+            <a:off x="10911535" y="6492240"/>
+            <a:ext cx="1097280" cy="274320"/>
+          </a:xfrm>
+          <a:prstGeom prst="rect">
+            <a:avLst/>
+          </a:prstGeom>
+          <a:noFill/>
+        </p:spPr>
+        <p:txBody>
+          <a:bodyPr wrap="none">
+            <a:spAutoFit/>
+          </a:bodyPr>
+          <a:lstStyle/>
+          <a:p>
+            <a:pPr algn="r"/>
+            <a:r>
+              <a:rPr sz="1100">
+                <a:solidFill>
+                  <a:srgbClr val="737A82"/>
+                </a:solidFill>
+              </a:rPr>
+              <a:t>15 / 23</a:t>
+            </a:r>
+          </a:p>
+        </p:txBody>
+      </p:sp>
     </p:spTree>
   </p:cSld>
   <p:clrMapOvr>
@@ -6330,6 +6636,40 @@
           </a:p>
         </p:txBody>
       </p:sp>
+      <p:sp>
+        <p:nvSpPr>
+          <p:cNvPr id="5" name="TextBox 4"/>
+          <p:cNvSpPr txBox="1"/>
+          <p:nvPr/>
+        </p:nvSpPr>
+        <p:spPr>
+          <a:xfrm>
+            <a:off x="10911535" y="6492240"/>
+            <a:ext cx="1097280" cy="274320"/>
+          </a:xfrm>
+          <a:prstGeom prst="rect">
+            <a:avLst/>
+          </a:prstGeom>
+          <a:noFill/>
+        </p:spPr>
+        <p:txBody>
+          <a:bodyPr wrap="none">
+            <a:spAutoFit/>
+          </a:bodyPr>
+          <a:lstStyle/>
+          <a:p>
+            <a:pPr algn="r"/>
+            <a:r>
+              <a:rPr sz="1100">
+                <a:solidFill>
+                  <a:srgbClr val="737A82"/>
+                </a:solidFill>
+              </a:rPr>
+              <a:t>16 / 23</a:t>
+            </a:r>
+          </a:p>
+        </p:txBody>
+      </p:sp>
     </p:spTree>
   </p:cSld>
   <p:clrMapOvr>
@@ -6473,6 +6813,40 @@
           </a:p>
         </p:txBody>
       </p:sp>
+      <p:sp>
+        <p:nvSpPr>
+          <p:cNvPr id="5" name="TextBox 4"/>
+          <p:cNvSpPr txBox="1"/>
+          <p:nvPr/>
+        </p:nvSpPr>
+        <p:spPr>
+          <a:xfrm>
+            <a:off x="10911535" y="6492240"/>
+            <a:ext cx="1097280" cy="274320"/>
+          </a:xfrm>
+          <a:prstGeom prst="rect">
+            <a:avLst/>
+          </a:prstGeom>
+          <a:noFill/>
+        </p:spPr>
+        <p:txBody>
+          <a:bodyPr wrap="none">
+            <a:spAutoFit/>
+          </a:bodyPr>
+          <a:lstStyle/>
+          <a:p>
+            <a:pPr algn="r"/>
+            <a:r>
+              <a:rPr sz="1100">
+                <a:solidFill>
+                  <a:srgbClr val="737A82"/>
+                </a:solidFill>
+              </a:rPr>
+              <a:t>17 / 23</a:t>
+            </a:r>
+          </a:p>
+        </p:txBody>
+      </p:sp>
     </p:spTree>
   </p:cSld>
   <p:clrMapOvr>
@@ -6592,6 +6966,40 @@
           </a:p>
         </p:txBody>
       </p:sp>
+      <p:sp>
+        <p:nvSpPr>
+          <p:cNvPr id="4" name="TextBox 3"/>
+          <p:cNvSpPr txBox="1"/>
+          <p:nvPr/>
+        </p:nvSpPr>
+        <p:spPr>
+          <a:xfrm>
+            <a:off x="10911535" y="6492240"/>
+            <a:ext cx="1097280" cy="274320"/>
+          </a:xfrm>
+          <a:prstGeom prst="rect">
+            <a:avLst/>
+          </a:prstGeom>
+          <a:noFill/>
+        </p:spPr>
+        <p:txBody>
+          <a:bodyPr wrap="none">
+            <a:spAutoFit/>
+          </a:bodyPr>
+          <a:lstStyle/>
+          <a:p>
+            <a:pPr algn="r"/>
+            <a:r>
+              <a:rPr sz="1100">
+                <a:solidFill>
+                  <a:srgbClr val="737A82"/>
+                </a:solidFill>
+              </a:rPr>
+              <a:t>18 / 23</a:t>
+            </a:r>
+          </a:p>
+        </p:txBody>
+      </p:sp>
     </p:spTree>
   </p:cSld>
   <p:clrMapOvr>
@@ -6668,6 +7076,40 @@
           </a:prstGeom>
         </p:spPr>
       </p:pic>
+      <p:sp>
+        <p:nvSpPr>
+          <p:cNvPr id="4" name="TextBox 3"/>
+          <p:cNvSpPr txBox="1"/>
+          <p:nvPr/>
+        </p:nvSpPr>
+        <p:spPr>
+          <a:xfrm>
+            <a:off x="10911535" y="6492240"/>
+            <a:ext cx="1097280" cy="274320"/>
+          </a:xfrm>
+          <a:prstGeom prst="rect">
+            <a:avLst/>
+          </a:prstGeom>
+          <a:noFill/>
+        </p:spPr>
+        <p:txBody>
+          <a:bodyPr wrap="none">
+            <a:spAutoFit/>
+          </a:bodyPr>
+          <a:lstStyle/>
+          <a:p>
+            <a:pPr algn="r"/>
+            <a:r>
+              <a:rPr sz="1100">
+                <a:solidFill>
+                  <a:srgbClr val="737A82"/>
+                </a:solidFill>
+              </a:rPr>
+              <a:t>1 / 23</a:t>
+            </a:r>
+          </a:p>
+        </p:txBody>
+      </p:sp>
     </p:spTree>
   </p:cSld>
   <p:clrMapOvr>
@@ -6811,6 +7253,40 @@
           </a:p>
         </p:txBody>
       </p:sp>
+      <p:sp>
+        <p:nvSpPr>
+          <p:cNvPr id="5" name="TextBox 4"/>
+          <p:cNvSpPr txBox="1"/>
+          <p:nvPr/>
+        </p:nvSpPr>
+        <p:spPr>
+          <a:xfrm>
+            <a:off x="10911535" y="6492240"/>
+            <a:ext cx="1097280" cy="274320"/>
+          </a:xfrm>
+          <a:prstGeom prst="rect">
+            <a:avLst/>
+          </a:prstGeom>
+          <a:noFill/>
+        </p:spPr>
+        <p:txBody>
+          <a:bodyPr wrap="none">
+            <a:spAutoFit/>
+          </a:bodyPr>
+          <a:lstStyle/>
+          <a:p>
+            <a:pPr algn="r"/>
+            <a:r>
+              <a:rPr sz="1100">
+                <a:solidFill>
+                  <a:srgbClr val="737A82"/>
+                </a:solidFill>
+              </a:rPr>
+              <a:t>19 / 23</a:t>
+            </a:r>
+          </a:p>
+        </p:txBody>
+      </p:sp>
     </p:spTree>
   </p:cSld>
   <p:clrMapOvr>
@@ -6954,6 +7430,40 @@
           </a:p>
         </p:txBody>
       </p:sp>
+      <p:sp>
+        <p:nvSpPr>
+          <p:cNvPr id="5" name="TextBox 4"/>
+          <p:cNvSpPr txBox="1"/>
+          <p:nvPr/>
+        </p:nvSpPr>
+        <p:spPr>
+          <a:xfrm>
+            <a:off x="10911535" y="6492240"/>
+            <a:ext cx="1097280" cy="274320"/>
+          </a:xfrm>
+          <a:prstGeom prst="rect">
+            <a:avLst/>
+          </a:prstGeom>
+          <a:noFill/>
+        </p:spPr>
+        <p:txBody>
+          <a:bodyPr wrap="none">
+            <a:spAutoFit/>
+          </a:bodyPr>
+          <a:lstStyle/>
+          <a:p>
+            <a:pPr algn="r"/>
+            <a:r>
+              <a:rPr sz="1100">
+                <a:solidFill>
+                  <a:srgbClr val="737A82"/>
+                </a:solidFill>
+              </a:rPr>
+              <a:t>20 / 23</a:t>
+            </a:r>
+          </a:p>
+        </p:txBody>
+      </p:sp>
     </p:spTree>
   </p:cSld>
   <p:clrMapOvr>
@@ -7073,6 +7583,40 @@
           </a:p>
         </p:txBody>
       </p:sp>
+      <p:sp>
+        <p:nvSpPr>
+          <p:cNvPr id="4" name="TextBox 3"/>
+          <p:cNvSpPr txBox="1"/>
+          <p:nvPr/>
+        </p:nvSpPr>
+        <p:spPr>
+          <a:xfrm>
+            <a:off x="10911535" y="6492240"/>
+            <a:ext cx="1097280" cy="274320"/>
+          </a:xfrm>
+          <a:prstGeom prst="rect">
+            <a:avLst/>
+          </a:prstGeom>
+          <a:noFill/>
+        </p:spPr>
+        <p:txBody>
+          <a:bodyPr wrap="none">
+            <a:spAutoFit/>
+          </a:bodyPr>
+          <a:lstStyle/>
+          <a:p>
+            <a:pPr algn="r"/>
+            <a:r>
+              <a:rPr sz="1100">
+                <a:solidFill>
+                  <a:srgbClr val="737A82"/>
+                </a:solidFill>
+              </a:rPr>
+              <a:t>21 / 23</a:t>
+            </a:r>
+          </a:p>
+        </p:txBody>
+      </p:sp>
     </p:spTree>
   </p:cSld>
   <p:clrMapOvr>
@@ -7277,6 +7821,40 @@
           </a:p>
         </p:txBody>
       </p:sp>
+      <p:sp>
+        <p:nvSpPr>
+          <p:cNvPr id="4" name="TextBox 3"/>
+          <p:cNvSpPr txBox="1"/>
+          <p:nvPr/>
+        </p:nvSpPr>
+        <p:spPr>
+          <a:xfrm>
+            <a:off x="10911535" y="6492240"/>
+            <a:ext cx="1097280" cy="274320"/>
+          </a:xfrm>
+          <a:prstGeom prst="rect">
+            <a:avLst/>
+          </a:prstGeom>
+          <a:noFill/>
+        </p:spPr>
+        <p:txBody>
+          <a:bodyPr wrap="none">
+            <a:spAutoFit/>
+          </a:bodyPr>
+          <a:lstStyle/>
+          <a:p>
+            <a:pPr algn="r"/>
+            <a:r>
+              <a:rPr sz="1100">
+                <a:solidFill>
+                  <a:srgbClr val="737A82"/>
+                </a:solidFill>
+              </a:rPr>
+              <a:t>22 / 23</a:t>
+            </a:r>
+          </a:p>
+        </p:txBody>
+      </p:sp>
     </p:spTree>
   </p:cSld>
   <p:clrMapOvr>
@@ -7396,6 +7974,40 @@
           </a:p>
         </p:txBody>
       </p:sp>
+      <p:sp>
+        <p:nvSpPr>
+          <p:cNvPr id="4" name="TextBox 3"/>
+          <p:cNvSpPr txBox="1"/>
+          <p:nvPr/>
+        </p:nvSpPr>
+        <p:spPr>
+          <a:xfrm>
+            <a:off x="10911535" y="6492240"/>
+            <a:ext cx="1097280" cy="274320"/>
+          </a:xfrm>
+          <a:prstGeom prst="rect">
+            <a:avLst/>
+          </a:prstGeom>
+          <a:noFill/>
+        </p:spPr>
+        <p:txBody>
+          <a:bodyPr wrap="none">
+            <a:spAutoFit/>
+          </a:bodyPr>
+          <a:lstStyle/>
+          <a:p>
+            <a:pPr algn="r"/>
+            <a:r>
+              <a:rPr sz="1100">
+                <a:solidFill>
+                  <a:srgbClr val="737A82"/>
+                </a:solidFill>
+              </a:rPr>
+              <a:t>23 / 23</a:t>
+            </a:r>
+          </a:p>
+        </p:txBody>
+      </p:sp>
     </p:spTree>
   </p:cSld>
   <p:clrMapOvr>
@@ -7528,6 +8140,40 @@
           </a:p>
         </p:txBody>
       </p:sp>
+      <p:sp>
+        <p:nvSpPr>
+          <p:cNvPr id="5" name="TextBox 4"/>
+          <p:cNvSpPr txBox="1"/>
+          <p:nvPr/>
+        </p:nvSpPr>
+        <p:spPr>
+          <a:xfrm>
+            <a:off x="10911535" y="6492240"/>
+            <a:ext cx="1097280" cy="274320"/>
+          </a:xfrm>
+          <a:prstGeom prst="rect">
+            <a:avLst/>
+          </a:prstGeom>
+          <a:noFill/>
+        </p:spPr>
+        <p:txBody>
+          <a:bodyPr wrap="none">
+            <a:spAutoFit/>
+          </a:bodyPr>
+          <a:lstStyle/>
+          <a:p>
+            <a:pPr algn="r"/>
+            <a:r>
+              <a:rPr sz="1100">
+                <a:solidFill>
+                  <a:srgbClr val="737A82"/>
+                </a:solidFill>
+              </a:rPr>
+              <a:t>2 / 23</a:t>
+            </a:r>
+          </a:p>
+        </p:txBody>
+      </p:sp>
     </p:spTree>
   </p:cSld>
   <p:clrMapOvr>
@@ -7671,6 +8317,40 @@
           </a:p>
         </p:txBody>
       </p:sp>
+      <p:sp>
+        <p:nvSpPr>
+          <p:cNvPr id="5" name="TextBox 4"/>
+          <p:cNvSpPr txBox="1"/>
+          <p:nvPr/>
+        </p:nvSpPr>
+        <p:spPr>
+          <a:xfrm>
+            <a:off x="10911535" y="6492240"/>
+            <a:ext cx="1097280" cy="274320"/>
+          </a:xfrm>
+          <a:prstGeom prst="rect">
+            <a:avLst/>
+          </a:prstGeom>
+          <a:noFill/>
+        </p:spPr>
+        <p:txBody>
+          <a:bodyPr wrap="none">
+            <a:spAutoFit/>
+          </a:bodyPr>
+          <a:lstStyle/>
+          <a:p>
+            <a:pPr algn="r"/>
+            <a:r>
+              <a:rPr sz="1100">
+                <a:solidFill>
+                  <a:srgbClr val="737A82"/>
+                </a:solidFill>
+              </a:rPr>
+              <a:t>3 / 23</a:t>
+            </a:r>
+          </a:p>
+        </p:txBody>
+      </p:sp>
     </p:spTree>
   </p:cSld>
   <p:clrMapOvr>
@@ -7803,6 +8483,40 @@
           </a:p>
         </p:txBody>
       </p:sp>
+      <p:sp>
+        <p:nvSpPr>
+          <p:cNvPr id="5" name="TextBox 4"/>
+          <p:cNvSpPr txBox="1"/>
+          <p:nvPr/>
+        </p:nvSpPr>
+        <p:spPr>
+          <a:xfrm>
+            <a:off x="10911535" y="6492240"/>
+            <a:ext cx="1097280" cy="274320"/>
+          </a:xfrm>
+          <a:prstGeom prst="rect">
+            <a:avLst/>
+          </a:prstGeom>
+          <a:noFill/>
+        </p:spPr>
+        <p:txBody>
+          <a:bodyPr wrap="none">
+            <a:spAutoFit/>
+          </a:bodyPr>
+          <a:lstStyle/>
+          <a:p>
+            <a:pPr algn="r"/>
+            <a:r>
+              <a:rPr sz="1100">
+                <a:solidFill>
+                  <a:srgbClr val="737A82"/>
+                </a:solidFill>
+              </a:rPr>
+              <a:t>4 / 23</a:t>
+            </a:r>
+          </a:p>
+        </p:txBody>
+      </p:sp>
     </p:spTree>
   </p:cSld>
   <p:clrMapOvr>
@@ -7946,6 +8660,40 @@
           </a:p>
         </p:txBody>
       </p:sp>
+      <p:sp>
+        <p:nvSpPr>
+          <p:cNvPr id="5" name="TextBox 4"/>
+          <p:cNvSpPr txBox="1"/>
+          <p:nvPr/>
+        </p:nvSpPr>
+        <p:spPr>
+          <a:xfrm>
+            <a:off x="10911535" y="6492240"/>
+            <a:ext cx="1097280" cy="274320"/>
+          </a:xfrm>
+          <a:prstGeom prst="rect">
+            <a:avLst/>
+          </a:prstGeom>
+          <a:noFill/>
+        </p:spPr>
+        <p:txBody>
+          <a:bodyPr wrap="none">
+            <a:spAutoFit/>
+          </a:bodyPr>
+          <a:lstStyle/>
+          <a:p>
+            <a:pPr algn="r"/>
+            <a:r>
+              <a:rPr sz="1100">
+                <a:solidFill>
+                  <a:srgbClr val="737A82"/>
+                </a:solidFill>
+              </a:rPr>
+              <a:t>5 / 23</a:t>
+            </a:r>
+          </a:p>
+        </p:txBody>
+      </p:sp>
     </p:spTree>
   </p:cSld>
   <p:clrMapOvr>
@@ -8089,6 +8837,40 @@
           </a:p>
         </p:txBody>
       </p:sp>
+      <p:sp>
+        <p:nvSpPr>
+          <p:cNvPr id="5" name="TextBox 4"/>
+          <p:cNvSpPr txBox="1"/>
+          <p:nvPr/>
+        </p:nvSpPr>
+        <p:spPr>
+          <a:xfrm>
+            <a:off x="10911535" y="6492240"/>
+            <a:ext cx="1097280" cy="274320"/>
+          </a:xfrm>
+          <a:prstGeom prst="rect">
+            <a:avLst/>
+          </a:prstGeom>
+          <a:noFill/>
+        </p:spPr>
+        <p:txBody>
+          <a:bodyPr wrap="none">
+            <a:spAutoFit/>
+          </a:bodyPr>
+          <a:lstStyle/>
+          <a:p>
+            <a:pPr algn="r"/>
+            <a:r>
+              <a:rPr sz="1100">
+                <a:solidFill>
+                  <a:srgbClr val="737A82"/>
+                </a:solidFill>
+              </a:rPr>
+              <a:t>6 / 23</a:t>
+            </a:r>
+          </a:p>
+        </p:txBody>
+      </p:sp>
     </p:spTree>
   </p:cSld>
   <p:clrMapOvr>
@@ -8221,6 +9003,40 @@
           </a:p>
         </p:txBody>
       </p:sp>
+      <p:sp>
+        <p:nvSpPr>
+          <p:cNvPr id="5" name="TextBox 4"/>
+          <p:cNvSpPr txBox="1"/>
+          <p:nvPr/>
+        </p:nvSpPr>
+        <p:spPr>
+          <a:xfrm>
+            <a:off x="10911535" y="6492240"/>
+            <a:ext cx="1097280" cy="274320"/>
+          </a:xfrm>
+          <a:prstGeom prst="rect">
+            <a:avLst/>
+          </a:prstGeom>
+          <a:noFill/>
+        </p:spPr>
+        <p:txBody>
+          <a:bodyPr wrap="none">
+            <a:spAutoFit/>
+          </a:bodyPr>
+          <a:lstStyle/>
+          <a:p>
+            <a:pPr algn="r"/>
+            <a:r>
+              <a:rPr sz="1100">
+                <a:solidFill>
+                  <a:srgbClr val="737A82"/>
+                </a:solidFill>
+              </a:rPr>
+              <a:t>7 / 23</a:t>
+            </a:r>
+          </a:p>
+        </p:txBody>
+      </p:sp>
     </p:spTree>
   </p:cSld>
   <p:clrMapOvr>
@@ -8349,6 +9165,40 @@
                 </a:solidFill>
               </a:rPr>
               <a:t>• Space amp — байт на диске на байт живых данных</a:t>
+            </a:r>
+          </a:p>
+        </p:txBody>
+      </p:sp>
+      <p:sp>
+        <p:nvSpPr>
+          <p:cNvPr id="5" name="TextBox 4"/>
+          <p:cNvSpPr txBox="1"/>
+          <p:nvPr/>
+        </p:nvSpPr>
+        <p:spPr>
+          <a:xfrm>
+            <a:off x="10911535" y="6492240"/>
+            <a:ext cx="1097280" cy="274320"/>
+          </a:xfrm>
+          <a:prstGeom prst="rect">
+            <a:avLst/>
+          </a:prstGeom>
+          <a:noFill/>
+        </p:spPr>
+        <p:txBody>
+          <a:bodyPr wrap="none">
+            <a:spAutoFit/>
+          </a:bodyPr>
+          <a:lstStyle/>
+          <a:p>
+            <a:pPr algn="r"/>
+            <a:r>
+              <a:rPr sz="1100">
+                <a:solidFill>
+                  <a:srgbClr val="737A82"/>
+                </a:solidFill>
+              </a:rPr>
+              <a:t>8 / 23</a:t>
             </a:r>
           </a:p>
         </p:txBody>

</xml_diff>

<commit_message>
stitching_workload: shift SY 80 -> 110 so the bracket caption clears the title
The '10% пересечения → слить' label is positioned at SY-50, which
sat at y=30 — overlapping the diagram title at y=10-38. Pushing SY
down by 30 puts the label at y=60, clear of the title with adequate
gap after the shrink to 720px width. Rebuilt the PPTX with the
updated SVG.
</commit_message>
<xml_diff>
--- a/talks/cpp-russia-lsm-compaction.pptx
+++ b/talks/cpp-russia-lsm-compaction.pptx
@@ -6724,7 +6724,7 @@
       </p:sp>
       <p:pic>
         <p:nvPicPr>
-          <p:cNvPr id="3" name="Picture 2" descr="stitching_workload_b1730fef6189.png"/>
+          <p:cNvPr id="3" name="Picture 2" descr="stitching_workload_633bd93114ea.png"/>
           <p:cNvPicPr>
             <a:picLocks noChangeAspect="1"/>
           </p:cNvPicPr>
@@ -6738,8 +6738,8 @@
         </p:blipFill>
         <p:spPr>
           <a:xfrm>
-            <a:off x="1562226" y="1186434"/>
-            <a:ext cx="9067243" cy="3387852"/>
+            <a:off x="1831961" y="1186434"/>
+            <a:ext cx="8527773" cy="3387852"/>
           </a:xfrm>
           <a:prstGeom prst="rect">
             <a:avLst/>

</xml_diff>